<commit_message>
docs: align pitch deck and runbook to R2S5
</commit_message>
<xml_diff>
--- a/submission/ControlPlane_Round2_Pitch.pptx
+++ b/submission/ControlPlane_Round2_Pitch.pptx
@@ -8093,8 +8093,47 @@
         </p:nvSpPr>
         <p:spPr>
           <a:xfrm>
-            <a:off x="1243584" y="7461504"/>
-            <a:ext cx="15819120" cy="1417320"/>
+            <a:off x="1243584" y="7424928"/>
+            <a:ext cx="15819120" cy="329184"/>
+          </a:xfrm>
+          <a:prstGeom prst="rect">
+            <a:avLst/>
+          </a:prstGeom>
+          <a:noFill/>
+          <a:ln/>
+        </p:spPr>
+        <p:txBody>
+          <a:bodyPr wrap="square" lIns="0" tIns="0" rIns="0" bIns="0" rtlCol="0" anchor="ctr"/>
+          <a:lstStyle/>
+          <a:p>
+            <a:pPr indent="0" marL="0">
+              <a:buNone/>
+            </a:pPr>
+            <a:r>
+              <a:rPr lang="en-US" sz="1400" dirty="0">
+                <a:solidFill>
+                  <a:srgbClr val="F2C572"/>
+                </a:solidFill>
+                <a:latin typeface="Arial" pitchFamily="34" charset="0"/>
+                <a:ea typeface="Arial" pitchFamily="34" charset="-122"/>
+                <a:cs typeface="Arial" pitchFamily="34" charset="-120"/>
+              </a:rPr>
+              <a:t>Measured gate (submission/latency_bench.json, n=200): p50≈0.074 ms · p95≈0.134 ms — under target; quote measured vs targets separately.</a:t>
+            </a:r>
+            <a:endParaRPr lang="en-US" sz="1400" dirty="0"/>
+          </a:p>
+        </p:txBody>
+      </p:sp>
+      <p:sp>
+        <p:nvSpPr>
+          <p:cNvPr id="53" name="Text 50"/>
+          <p:cNvSpPr/>
+          <p:nvPr/>
+        </p:nvSpPr>
+        <p:spPr>
+          <a:xfrm>
+            <a:off x="1243584" y="7772400"/>
+            <a:ext cx="15819120" cy="1234440"/>
           </a:xfrm>
           <a:prstGeom prst="rect">
             <a:avLst/>

</xml_diff>

<commit_message>
F5+F6: publish the measured miss in all three artifacts; fix clean-clone failure
F6 clean-clone test (first time run this week) caught a real bug: pypdf was not in
the dev extras, so on a fresh clone scripts/verify.py could not read the README PDF
and test_verify_passes_on_consistent_tree failed. Worse, test_content_laws.py
silently skipped PDF and PPTX scanning without pypdf, so content laws were passing
vacuously on any clean clone. Added pypdf>=4.0 to dev; verified 13/13 pass on the
fresh clone afterwards.

F5: all three artifacts now carry the honesty disclosures, from frozen numbers in
evals/last_run.json (168 cases, ungrounded FNR 1.1% CI 0.19-5.78%, passable FPR 0.0%
upper bound 15.5%, hard-negative hold 64% CI 50.7-75.7%). README PDF and pitch deck
gained the self-authored-corpus caveat and the refuse-to-claim list; the deck gained
a measured/refuse slide (13 -> 14 slides).

Verified: pytest -q -> 340 passed, 2 skipped, 0 failed.
</commit_message>
<xml_diff>
--- a/submission/ControlPlane_Round2_Pitch.pptx
+++ b/submission/ControlPlane_Round2_Pitch.pptx
@@ -18,9 +18,10 @@
     <p:sldId id="266" r:id="rId12"/>
     <p:sldId id="267" r:id="rId13"/>
     <p:sldId id="268" r:id="rId14"/>
+    <p:sldId id="269" r:id="rId15"/>
   </p:sldIdLst>
   <p:notesMasterIdLst>
-    <p:notesMasterId r:id="rId15"/>
+    <p:notesMasterId r:id="rId16"/>
   </p:notesMasterIdLst>
   <p:sldSz cx="18288000" cy="10287000"/>
   <p:notesSz cx="10287000" cy="18288000"/>
@@ -866,7 +867,7 @@
           <a:p>
             <a:r>
               <a:rPr lang="en-US" dirty="0"/>
-              <a:t>We are asking to take this into shadow on one support route and one acting route. Enforcement is earned per route. The first artefact you get is the counterfactual — would have held N, of which M were true positives — not a block. That system was never asked to prove anything. Now nothing acts until it can prove it should.</a:t>
+              <a:t>This is the honesty slide. Every number here is measured by make eval and make bench on a 168-case self-authored corpus — no production traffic. Ungrounded FNR is 1.1 percent with a Wilson interval of 0.19 to 5.78. Passable-action FPR is 0.0 percent with a 15.5 percent upper bound. The hard-negative hold rate is 64 percent — we over-flag, and we name that as the next milestone rather than hide it. Gate latency over ten thousand runs is p50 0.44ms, p95 0.52ms, p99 0.64ms. Then the refusals, about us and never about competitors: we do not claim eliminated hallucinations, zero integration, zero added latency, one accuracy number, or production-scale proof. In the demo the refund was held and escalated with the evidence packet.</a:t>
             </a:r>
             <a:endParaRPr lang="en-US" dirty="0"/>
           </a:p>
@@ -890,6 +891,94 @@
             <a:fld id="{F7021451-1387-4CA6-816F-3879F97B5CBC}" type="slidenum">
               <a:rPr lang="en-US"/>
               <a:t>13</a:t>
+            </a:fld>
+            <a:endParaRPr lang="en-US"/>
+          </a:p>
+        </p:txBody>
+      </p:sp>
+    </p:spTree>
+    <p:extLst>
+      <p:ext uri="{BB962C8B-B14F-4D97-AF65-F5344CB8AC3E}">
+        <p14:creationId xmlns:p14="http://schemas.microsoft.com/office/powerpoint/2010/main" val="1024086991"/>
+      </p:ext>
+    </p:extLst>
+  </p:cSld>
+  <p:clrMapOvr>
+    <a:masterClrMapping/>
+  </p:clrMapOvr>
+</p:notes>
+</file>
+
+<file path=ppt/notesSlides/notesSlide14.xml><?xml version="1.0" encoding="utf-8"?>
+<p:notes xmlns:a="http://schemas.openxmlformats.org/drawingml/2006/main" xmlns:r="http://schemas.openxmlformats.org/officeDocument/2006/relationships" xmlns:p="http://schemas.openxmlformats.org/presentationml/2006/main">
+  <p:cSld>
+    <p:spTree>
+      <p:nvGrpSpPr>
+        <p:cNvPr id="1" name=""/>
+        <p:cNvGrpSpPr/>
+        <p:nvPr/>
+      </p:nvGrpSpPr>
+      <p:grpSpPr>
+        <a:xfrm>
+          <a:off x="0" y="0"/>
+          <a:ext cx="0" cy="0"/>
+          <a:chOff x="0" y="0"/>
+          <a:chExt cx="0" cy="0"/>
+        </a:xfrm>
+      </p:grpSpPr>
+      <p:sp>
+        <p:nvSpPr>
+          <p:cNvPr id="2" name="Slide Image Placeholder 1"/>
+          <p:cNvSpPr>
+            <a:spLocks noGrp="1" noRot="1" noChangeAspect="1"/>
+          </p:cNvSpPr>
+          <p:nvPr>
+            <p:ph type="sldImg"/>
+          </p:nvPr>
+        </p:nvSpPr>
+        <p:spPr/>
+      </p:sp>
+      <p:sp>
+        <p:nvSpPr>
+          <p:cNvPr id="3" name="Notes Placeholder 2"/>
+          <p:cNvSpPr>
+            <a:spLocks noGrp="1"/>
+          </p:cNvSpPr>
+          <p:nvPr>
+            <p:ph type="body" idx="1"/>
+          </p:nvPr>
+        </p:nvSpPr>
+        <p:spPr/>
+        <p:txBody>
+          <a:bodyPr/>
+          <a:lstStyle/>
+          <a:p>
+            <a:r>
+              <a:rPr lang="en-US" dirty="0"/>
+              <a:t>We are asking to take this into shadow on one support route and one acting route. Enforcement is earned per route. The first artefact you get is the counterfactual — would have held N, of which M were true positives — not a block. That system was never asked to prove anything. Now nothing acts until it can prove it should.</a:t>
+            </a:r>
+            <a:endParaRPr lang="en-US" dirty="0"/>
+          </a:p>
+        </p:txBody>
+      </p:sp>
+      <p:sp>
+        <p:nvSpPr>
+          <p:cNvPr id="4" name="Slide Number Placeholder 3"/>
+          <p:cNvSpPr>
+            <a:spLocks noGrp="1"/>
+          </p:cNvSpPr>
+          <p:nvPr>
+            <p:ph type="sldNum" sz="quarter" idx="10"/>
+          </p:nvPr>
+        </p:nvSpPr>
+        <p:spPr/>
+        <p:txBody>
+          <a:bodyPr/>
+          <a:lstStyle/>
+          <a:p>
+            <a:fld id="{F7021451-1387-4CA6-816F-3879F97B5CBC}" type="slidenum">
+              <a:rPr lang="en-US"/>
+              <a:t>14</a:t>
             </a:fld>
             <a:endParaRPr lang="en-US"/>
           </a:p>
@@ -9351,6 +9440,1247 @@
     <p:bg>
       <p:bgPr>
         <a:solidFill>
+          <a:srgbClr val="120806"/>
+        </a:solidFill>
+      </p:bgPr>
+    </p:bg>
+    <p:spTree>
+      <p:nvGrpSpPr>
+        <p:cNvPr id="1" name=""/>
+        <p:cNvGrpSpPr/>
+        <p:nvPr/>
+      </p:nvGrpSpPr>
+      <p:grpSpPr>
+        <a:xfrm>
+          <a:off x="0" y="0"/>
+          <a:ext cx="0" cy="0"/>
+          <a:chOff x="0" y="0"/>
+          <a:chExt cx="0" cy="0"/>
+        </a:xfrm>
+      </p:grpSpPr>
+      <p:sp>
+        <p:nvSpPr>
+          <p:cNvPr id="2" name="Shape 0"/>
+          <p:cNvSpPr/>
+          <p:nvPr/>
+        </p:nvSpPr>
+        <p:spPr>
+          <a:xfrm>
+            <a:off x="0" y="0"/>
+            <a:ext cx="18288000" cy="10287000"/>
+          </a:xfrm>
+          <a:prstGeom prst="rect">
+            <a:avLst/>
+          </a:prstGeom>
+          <a:solidFill>
+            <a:srgbClr val="2A120C">
+              <a:alpha val="30000"/>
+            </a:srgbClr>
+          </a:solidFill>
+          <a:ln/>
+        </p:spPr>
+      </p:sp>
+      <p:sp>
+        <p:nvSpPr>
+          <p:cNvPr id="3" name="Text 1"/>
+          <p:cNvSpPr/>
+          <p:nvPr/>
+        </p:nvSpPr>
+        <p:spPr>
+          <a:xfrm>
+            <a:off x="384048" y="402336"/>
+            <a:ext cx="210312" cy="228600"/>
+          </a:xfrm>
+          <a:prstGeom prst="rect">
+            <a:avLst/>
+          </a:prstGeom>
+          <a:noFill/>
+          <a:ln/>
+        </p:spPr>
+        <p:txBody>
+          <a:bodyPr wrap="square" lIns="0" tIns="0" rIns="0" bIns="0" rtlCol="0" anchor="ctr"/>
+          <a:lstStyle/>
+          <a:p>
+            <a:pPr indent="0" marL="0">
+              <a:buNone/>
+            </a:pPr>
+            <a:r>
+              <a:rPr lang="en-US" sz="1200" dirty="0">
+                <a:solidFill>
+                  <a:srgbClr val="D9482A"/>
+                </a:solidFill>
+                <a:latin typeface="Arial" pitchFamily="34" charset="0"/>
+                <a:ea typeface="Arial" pitchFamily="34" charset="-122"/>
+                <a:cs typeface="Arial" pitchFamily="34" charset="-120"/>
+              </a:rPr>
+              <a:t>◢</a:t>
+            </a:r>
+            <a:endParaRPr lang="en-US" sz="1200" dirty="0"/>
+          </a:p>
+        </p:txBody>
+      </p:sp>
+      <p:sp>
+        <p:nvSpPr>
+          <p:cNvPr id="4" name="Text 2"/>
+          <p:cNvSpPr/>
+          <p:nvPr/>
+        </p:nvSpPr>
+        <p:spPr>
+          <a:xfrm>
+            <a:off x="621792" y="384048"/>
+            <a:ext cx="3840480" cy="265176"/>
+          </a:xfrm>
+          <a:prstGeom prst="rect">
+            <a:avLst/>
+          </a:prstGeom>
+          <a:noFill/>
+          <a:ln/>
+        </p:spPr>
+        <p:txBody>
+          <a:bodyPr wrap="square" lIns="0" tIns="0" rIns="0" bIns="0" rtlCol="0" anchor="ctr"/>
+          <a:lstStyle/>
+          <a:p>
+            <a:pPr indent="0" marL="0">
+              <a:buNone/>
+            </a:pPr>
+            <a:r>
+              <a:rPr lang="en-US" sz="1500" spc="150" kern="0" dirty="0">
+                <a:solidFill>
+                  <a:srgbClr val="F2E3D5"/>
+                </a:solidFill>
+                <a:latin typeface="Arial" pitchFamily="34" charset="0"/>
+                <a:ea typeface="Arial" pitchFamily="34" charset="-122"/>
+                <a:cs typeface="Arial" pitchFamily="34" charset="-120"/>
+              </a:rPr>
+              <a:t>CONTROLPLANE//SYS</a:t>
+            </a:r>
+            <a:endParaRPr lang="en-US" sz="1500" dirty="0"/>
+          </a:p>
+        </p:txBody>
+      </p:sp>
+      <p:sp>
+        <p:nvSpPr>
+          <p:cNvPr id="5" name="Text 3"/>
+          <p:cNvSpPr/>
+          <p:nvPr/>
+        </p:nvSpPr>
+        <p:spPr>
+          <a:xfrm>
+            <a:off x="11521440" y="384048"/>
+            <a:ext cx="6217920" cy="265176"/>
+          </a:xfrm>
+          <a:prstGeom prst="rect">
+            <a:avLst/>
+          </a:prstGeom>
+          <a:noFill/>
+          <a:ln/>
+        </p:spPr>
+        <p:txBody>
+          <a:bodyPr wrap="square" lIns="0" tIns="0" rIns="0" bIns="0" rtlCol="0" anchor="ctr"/>
+          <a:lstStyle/>
+          <a:p>
+            <a:pPr algn="r" indent="0" marL="0">
+              <a:buNone/>
+            </a:pPr>
+            <a:r>
+              <a:rPr lang="en-US" sz="1500" spc="150" kern="0" dirty="0">
+                <a:solidFill>
+                  <a:srgbClr val="7A5D4E"/>
+                </a:solidFill>
+                <a:latin typeface="Arial" pitchFamily="34" charset="0"/>
+                <a:ea typeface="Arial" pitchFamily="34" charset="-122"/>
+                <a:cs typeface="Arial" pitchFamily="34" charset="-120"/>
+              </a:rPr>
+              <a:t>11 // MEASURED</a:t>
+            </a:r>
+            <a:endParaRPr lang="en-US" sz="1500" dirty="0"/>
+          </a:p>
+        </p:txBody>
+      </p:sp>
+      <p:sp>
+        <p:nvSpPr>
+          <p:cNvPr id="6" name="Text 4"/>
+          <p:cNvSpPr/>
+          <p:nvPr/>
+        </p:nvSpPr>
+        <p:spPr>
+          <a:xfrm>
+            <a:off x="17775936" y="402336"/>
+            <a:ext cx="210312" cy="228600"/>
+          </a:xfrm>
+          <a:prstGeom prst="rect">
+            <a:avLst/>
+          </a:prstGeom>
+          <a:noFill/>
+          <a:ln/>
+        </p:spPr>
+        <p:txBody>
+          <a:bodyPr wrap="square" lIns="0" tIns="0" rIns="0" bIns="0" rtlCol="0" anchor="ctr"/>
+          <a:lstStyle/>
+          <a:p>
+            <a:pPr indent="0" marL="0">
+              <a:buNone/>
+            </a:pPr>
+            <a:r>
+              <a:rPr lang="en-US" sz="1200" dirty="0">
+                <a:solidFill>
+                  <a:srgbClr val="D9482A"/>
+                </a:solidFill>
+                <a:latin typeface="Arial" pitchFamily="34" charset="0"/>
+                <a:ea typeface="Arial" pitchFamily="34" charset="-122"/>
+                <a:cs typeface="Arial" pitchFamily="34" charset="-120"/>
+              </a:rPr>
+              <a:t>◣</a:t>
+            </a:r>
+            <a:endParaRPr lang="en-US" sz="1200" dirty="0"/>
+          </a:p>
+        </p:txBody>
+      </p:sp>
+      <p:sp>
+        <p:nvSpPr>
+          <p:cNvPr id="7" name="Shape 5"/>
+          <p:cNvSpPr/>
+          <p:nvPr/>
+        </p:nvSpPr>
+        <p:spPr>
+          <a:xfrm>
+            <a:off x="384048" y="9747504"/>
+            <a:ext cx="91440" cy="91440"/>
+          </a:xfrm>
+          <a:prstGeom prst="rect">
+            <a:avLst/>
+          </a:prstGeom>
+          <a:solidFill>
+            <a:srgbClr val="D9482A"/>
+          </a:solidFill>
+          <a:ln/>
+        </p:spPr>
+      </p:sp>
+      <p:sp>
+        <p:nvSpPr>
+          <p:cNvPr id="8" name="Text 6"/>
+          <p:cNvSpPr/>
+          <p:nvPr/>
+        </p:nvSpPr>
+        <p:spPr>
+          <a:xfrm>
+            <a:off x="566928" y="9683496"/>
+            <a:ext cx="2194560" cy="265176"/>
+          </a:xfrm>
+          <a:prstGeom prst="rect">
+            <a:avLst/>
+          </a:prstGeom>
+          <a:noFill/>
+          <a:ln/>
+        </p:spPr>
+        <p:txBody>
+          <a:bodyPr wrap="square" lIns="0" tIns="0" rIns="0" bIns="0" rtlCol="0" anchor="ctr"/>
+          <a:lstStyle/>
+          <a:p>
+            <a:pPr indent="0" marL="0">
+              <a:buNone/>
+            </a:pPr>
+            <a:r>
+              <a:rPr lang="en-US" sz="1500" dirty="0">
+                <a:solidFill>
+                  <a:srgbClr val="7A5D4E"/>
+                </a:solidFill>
+                <a:latin typeface="Arial" pitchFamily="34" charset="0"/>
+                <a:ea typeface="Arial" pitchFamily="34" charset="-122"/>
+                <a:cs typeface="Arial" pitchFamily="34" charset="-120"/>
+              </a:rPr>
+              <a:t>ADMIT//PROVE</a:t>
+            </a:r>
+            <a:endParaRPr lang="en-US" sz="1500" dirty="0"/>
+          </a:p>
+        </p:txBody>
+      </p:sp>
+      <p:sp>
+        <p:nvSpPr>
+          <p:cNvPr id="9" name="Text 7"/>
+          <p:cNvSpPr/>
+          <p:nvPr/>
+        </p:nvSpPr>
+        <p:spPr>
+          <a:xfrm>
+            <a:off x="13350240" y="9683496"/>
+            <a:ext cx="4480560" cy="265176"/>
+          </a:xfrm>
+          <a:prstGeom prst="rect">
+            <a:avLst/>
+          </a:prstGeom>
+          <a:noFill/>
+          <a:ln/>
+        </p:spPr>
+        <p:txBody>
+          <a:bodyPr wrap="square" lIns="0" tIns="0" rIns="0" bIns="0" rtlCol="0" anchor="ctr"/>
+          <a:lstStyle/>
+          <a:p>
+            <a:pPr algn="r" indent="0" marL="0">
+              <a:buNone/>
+            </a:pPr>
+            <a:r>
+              <a:rPr lang="en-US" sz="1500" spc="150" kern="0" dirty="0">
+                <a:solidFill>
+                  <a:srgbClr val="7A5D4E"/>
+                </a:solidFill>
+                <a:latin typeface="Arial" pitchFamily="34" charset="0"/>
+                <a:ea typeface="Arial" pitchFamily="34" charset="-122"/>
+                <a:cs typeface="Arial" pitchFamily="34" charset="-120"/>
+              </a:rPr>
+              <a:t>AIC.2026 · PS #1 · IITGN</a:t>
+            </a:r>
+            <a:endParaRPr lang="en-US" sz="1500" dirty="0"/>
+          </a:p>
+        </p:txBody>
+      </p:sp>
+      <p:sp>
+        <p:nvSpPr>
+          <p:cNvPr id="11" name="Text 8"/>
+          <p:cNvSpPr/>
+          <p:nvPr/>
+        </p:nvSpPr>
+        <p:spPr>
+          <a:xfrm>
+            <a:off x="950976" y="914400"/>
+            <a:ext cx="12801600" cy="265176"/>
+          </a:xfrm>
+          <a:prstGeom prst="rect">
+            <a:avLst/>
+          </a:prstGeom>
+          <a:noFill/>
+          <a:ln/>
+        </p:spPr>
+        <p:txBody>
+          <a:bodyPr wrap="square" lIns="0" tIns="0" rIns="0" bIns="0" rtlCol="0" anchor="ctr"/>
+          <a:lstStyle/>
+          <a:p>
+            <a:pPr algn="l" indent="0" marL="0">
+              <a:buNone/>
+            </a:pPr>
+            <a:r>
+              <a:rPr lang="en-US" sz="1500" spc="300" kern="0" dirty="0">
+                <a:solidFill>
+                  <a:srgbClr val="D9482A"/>
+                </a:solidFill>
+                <a:latin typeface="Arial" pitchFamily="34" charset="0"/>
+                <a:ea typeface="Arial" pitchFamily="34" charset="-122"/>
+                <a:cs typeface="Arial" pitchFamily="34" charset="-120"/>
+              </a:rPr>
+              <a:t>12 · WHAT WE MEASURED  ·  AND WHAT WE REFUSE TO CLAIM</a:t>
+            </a:r>
+            <a:endParaRPr lang="en-US" sz="1500" dirty="0"/>
+          </a:p>
+        </p:txBody>
+      </p:sp>
+      <p:sp>
+        <p:nvSpPr>
+          <p:cNvPr id="12" name="Text 9"/>
+          <p:cNvSpPr/>
+          <p:nvPr/>
+        </p:nvSpPr>
+        <p:spPr>
+          <a:xfrm>
+            <a:off x="950976" y="1207008"/>
+            <a:ext cx="16367760" cy="475488"/>
+          </a:xfrm>
+          <a:prstGeom prst="rect">
+            <a:avLst/>
+          </a:prstGeom>
+          <a:noFill/>
+          <a:ln/>
+        </p:spPr>
+        <p:txBody>
+          <a:bodyPr wrap="square" lIns="0" tIns="0" rIns="0" bIns="0" rtlCol="0" anchor="t"/>
+          <a:lstStyle/>
+          <a:p>
+            <a:pPr algn="l" indent="0" marL="0">
+              <a:buNone/>
+            </a:pPr>
+            <a:r>
+              <a:rPr lang="en-US" sz="2800" b="1" spc="-75" kern="0" dirty="0">
+                <a:solidFill>
+                  <a:srgbClr val="F2E3D5"/>
+                </a:solidFill>
+                <a:latin typeface="Arial" pitchFamily="34" charset="0"/>
+                <a:ea typeface="Arial" pitchFamily="34" charset="-122"/>
+                <a:cs typeface="Arial" pitchFamily="34" charset="-120"/>
+              </a:rPr>
+              <a:t>168 CASES. </a:t>
+            </a:r>
+            <a:pPr algn="l" indent="0" marL="0">
+              <a:buNone/>
+            </a:pPr>
+            <a:r>
+              <a:rPr lang="en-US" sz="2800" b="1" spc="-75" kern="0" dirty="0">
+                <a:solidFill>
+                  <a:srgbClr val="D9482A"/>
+                </a:solidFill>
+                <a:latin typeface="Arial" pitchFamily="34" charset="0"/>
+                <a:ea typeface="Arial" pitchFamily="34" charset="-122"/>
+                <a:cs typeface="Arial" pitchFamily="34" charset="-120"/>
+              </a:rPr>
+              <a:t>SELF-AUTHORED</a:t>
+            </a:r>
+            <a:pPr algn="l" indent="0" marL="0">
+              <a:buNone/>
+            </a:pPr>
+            <a:r>
+              <a:rPr lang="en-US" sz="2800" b="1" spc="-75" kern="0" dirty="0">
+                <a:solidFill>
+                  <a:srgbClr val="F2E3D5"/>
+                </a:solidFill>
+                <a:latin typeface="Arial" pitchFamily="34" charset="0"/>
+                <a:ea typeface="Arial" pitchFamily="34" charset="-122"/>
+                <a:cs typeface="Arial" pitchFamily="34" charset="-120"/>
+              </a:rPr>
+              <a:t>. NO PRODUCTION TRAFFIC.</a:t>
+            </a:r>
+            <a:endParaRPr lang="en-US" sz="2800" dirty="0"/>
+          </a:p>
+        </p:txBody>
+      </p:sp>
+      <p:sp>
+        <p:nvSpPr>
+          <p:cNvPr id="13" name="Text 10"/>
+          <p:cNvSpPr/>
+          <p:nvPr/>
+        </p:nvSpPr>
+        <p:spPr>
+          <a:xfrm>
+            <a:off x="950976" y="1719072"/>
+            <a:ext cx="16367760" cy="292608"/>
+          </a:xfrm>
+          <a:prstGeom prst="rect">
+            <a:avLst/>
+          </a:prstGeom>
+          <a:noFill/>
+          <a:ln/>
+        </p:spPr>
+        <p:txBody>
+          <a:bodyPr wrap="square" lIns="0" tIns="0" rIns="0" bIns="0" rtlCol="0" anchor="ctr"/>
+          <a:lstStyle/>
+          <a:p>
+            <a:pPr indent="0" marL="0">
+              <a:buNone/>
+            </a:pPr>
+            <a:r>
+              <a:rPr lang="en-US" sz="1500" dirty="0">
+                <a:solidFill>
+                  <a:srgbClr val="C9B5A3"/>
+                </a:solidFill>
+                <a:latin typeface="Arial" pitchFamily="34" charset="0"/>
+                <a:ea typeface="Arial" pitchFamily="34" charset="-122"/>
+                <a:cs typeface="Arial" pitchFamily="34" charset="-120"/>
+              </a:rPr>
+              <a:t>Every number below regenerates from `make eval` and `make bench`. Intervals, not point estimates. The miss is published, not smoothed.</a:t>
+            </a:r>
+            <a:endParaRPr lang="en-US" sz="1500" dirty="0"/>
+          </a:p>
+        </p:txBody>
+      </p:sp>
+      <p:sp>
+        <p:nvSpPr>
+          <p:cNvPr id="14" name="Shape 11"/>
+          <p:cNvSpPr/>
+          <p:nvPr/>
+        </p:nvSpPr>
+        <p:spPr>
+          <a:xfrm>
+            <a:off x="950976" y="2121408"/>
+            <a:ext cx="9281160" cy="4864608"/>
+          </a:xfrm>
+          <a:prstGeom prst="rect">
+            <a:avLst/>
+          </a:prstGeom>
+          <a:solidFill>
+            <a:srgbClr val="1A0D0A"/>
+          </a:solidFill>
+          <a:ln w="8636">
+            <a:solidFill>
+              <a:srgbClr val="5A2E20"/>
+            </a:solidFill>
+            <a:prstDash val="solid"/>
+          </a:ln>
+        </p:spPr>
+      </p:sp>
+      <p:sp>
+        <p:nvSpPr>
+          <p:cNvPr id="15" name="Shape 12"/>
+          <p:cNvSpPr/>
+          <p:nvPr/>
+        </p:nvSpPr>
+        <p:spPr>
+          <a:xfrm>
+            <a:off x="960120" y="2560320"/>
+            <a:ext cx="9262872" cy="9144"/>
+          </a:xfrm>
+          <a:prstGeom prst="rect">
+            <a:avLst/>
+          </a:prstGeom>
+          <a:solidFill>
+            <a:srgbClr val="3A1E16"/>
+          </a:solidFill>
+          <a:ln/>
+        </p:spPr>
+      </p:sp>
+      <p:sp>
+        <p:nvSpPr>
+          <p:cNvPr id="16" name="Text 13"/>
+          <p:cNvSpPr/>
+          <p:nvPr/>
+        </p:nvSpPr>
+        <p:spPr>
+          <a:xfrm>
+            <a:off x="1115568" y="2194560"/>
+            <a:ext cx="4810658" cy="292608"/>
+          </a:xfrm>
+          <a:prstGeom prst="rect">
+            <a:avLst/>
+          </a:prstGeom>
+          <a:noFill/>
+          <a:ln/>
+        </p:spPr>
+        <p:txBody>
+          <a:bodyPr wrap="square" lIns="0" tIns="0" rIns="0" bIns="0" rtlCol="0" anchor="ctr"/>
+          <a:lstStyle/>
+          <a:p>
+            <a:pPr indent="0" marL="0">
+              <a:buNone/>
+            </a:pPr>
+            <a:r>
+              <a:rPr lang="en-US" sz="1300" spc="120" kern="0" dirty="0">
+                <a:solidFill>
+                  <a:srgbClr val="7A5D4E"/>
+                </a:solidFill>
+                <a:latin typeface="Arial" pitchFamily="34" charset="0"/>
+                <a:ea typeface="Arial" pitchFamily="34" charset="-122"/>
+                <a:cs typeface="Arial" pitchFamily="34" charset="-120"/>
+              </a:rPr>
+              <a:t>▸ MEASURED — evals/last_run.json</a:t>
+            </a:r>
+            <a:endParaRPr lang="en-US" sz="1300" dirty="0"/>
+          </a:p>
+        </p:txBody>
+      </p:sp>
+      <p:sp>
+        <p:nvSpPr>
+          <p:cNvPr id="17" name="Text 14"/>
+          <p:cNvSpPr/>
+          <p:nvPr/>
+        </p:nvSpPr>
+        <p:spPr>
+          <a:xfrm>
+            <a:off x="6334049" y="2194560"/>
+            <a:ext cx="3715207" cy="292608"/>
+          </a:xfrm>
+          <a:prstGeom prst="rect">
+            <a:avLst/>
+          </a:prstGeom>
+          <a:noFill/>
+          <a:ln/>
+        </p:spPr>
+        <p:txBody>
+          <a:bodyPr wrap="square" lIns="0" tIns="0" rIns="0" bIns="0" rtlCol="0" anchor="ctr"/>
+          <a:lstStyle/>
+          <a:p>
+            <a:pPr algn="r" indent="0" marL="0">
+              <a:buNone/>
+            </a:pPr>
+            <a:r>
+              <a:rPr lang="en-US" sz="1300" spc="100" kern="0" dirty="0">
+                <a:solidFill>
+                  <a:srgbClr val="7A5D4E"/>
+                </a:solidFill>
+                <a:latin typeface="Arial" pitchFamily="34" charset="0"/>
+                <a:ea typeface="Arial" pitchFamily="34" charset="-122"/>
+                <a:cs typeface="Arial" pitchFamily="34" charset="-120"/>
+              </a:rPr>
+              <a:t>168 CASES · SELF-AUTHORED</a:t>
+            </a:r>
+            <a:endParaRPr lang="en-US" sz="1300" dirty="0"/>
+          </a:p>
+        </p:txBody>
+      </p:sp>
+      <p:sp>
+        <p:nvSpPr>
+          <p:cNvPr id="18" name="Text 15"/>
+          <p:cNvSpPr/>
+          <p:nvPr/>
+        </p:nvSpPr>
+        <p:spPr>
+          <a:xfrm>
+            <a:off x="1207008" y="2724912"/>
+            <a:ext cx="8778240" cy="4023360"/>
+          </a:xfrm>
+          <a:prstGeom prst="rect">
+            <a:avLst/>
+          </a:prstGeom>
+          <a:noFill/>
+          <a:ln/>
+        </p:spPr>
+        <p:txBody>
+          <a:bodyPr wrap="square" lIns="0" tIns="0" rIns="0" bIns="0" rtlCol="0" anchor="t"/>
+          <a:lstStyle/>
+          <a:p>
+            <a:pPr indent="0" marL="0">
+              <a:buNone/>
+            </a:pPr>
+            <a:r>
+              <a:rPr lang="en-US" sz="1400" dirty="0">
+                <a:solidFill>
+                  <a:srgbClr val="C9B5A3"/>
+                </a:solidFill>
+                <a:latin typeface="Courier New" pitchFamily="34" charset="0"/>
+                <a:ea typeface="Courier New" pitchFamily="34" charset="-122"/>
+                <a:cs typeface="Courier New" pitchFamily="34" charset="-120"/>
+              </a:rPr>
+              <a:t>corpus                    168 cases, self-authored</a:t>
+            </a:r>
+            <a:endParaRPr lang="en-US" sz="1400" dirty="0"/>
+          </a:p>
+          <a:p>
+            <a:pPr indent="0" marL="0">
+              <a:buNone/>
+            </a:pPr>
+            <a:r>
+              <a:rPr lang="en-US" sz="1400" dirty="0">
+                <a:solidFill>
+                  <a:srgbClr val="C9B5A3"/>
+                </a:solidFill>
+                <a:latin typeface="Courier New" pitchFamily="34" charset="0"/>
+                <a:ea typeface="Courier New" pitchFamily="34" charset="-122"/>
+                <a:cs typeface="Courier New" pitchFamily="34" charset="-120"/>
+              </a:rPr>
+              <a:t>production traffic        none</a:t>
+            </a:r>
+            <a:endParaRPr lang="en-US" sz="1400" dirty="0"/>
+          </a:p>
+          <a:p>
+            <a:pPr indent="0" marL="0">
+              <a:buNone/>
+            </a:pPr>
+            <a:r>
+              <a:rPr lang="en-US" sz="1400" dirty="0">
+                <a:solidFill>
+                  <a:srgbClr val="C9B5A3"/>
+                </a:solidFill>
+                <a:latin typeface="Courier New" pitchFamily="34" charset="0"/>
+                <a:ea typeface="Courier New" pitchFamily="34" charset="-122"/>
+                <a:cs typeface="Courier New" pitchFamily="34" charset="-120"/>
+              </a:rPr>
+              <a:t>ungrounded FNR            1.1%   95% CI 0.19% - 5.78%</a:t>
+            </a:r>
+            <a:endParaRPr lang="en-US" sz="1400" dirty="0"/>
+          </a:p>
+          <a:p>
+            <a:pPr indent="0" marL="0">
+              <a:buNone/>
+            </a:pPr>
+            <a:r>
+              <a:rPr lang="en-US" sz="1400" dirty="0">
+                <a:solidFill>
+                  <a:srgbClr val="C9B5A3"/>
+                </a:solidFill>
+                <a:latin typeface="Courier New" pitchFamily="34" charset="0"/>
+                <a:ea typeface="Courier New" pitchFamily="34" charset="-122"/>
+                <a:cs typeface="Courier New" pitchFamily="34" charset="-120"/>
+              </a:rPr>
+              <a:t>passable-action FPR       0.0%   95% upper bound 15.5%</a:t>
+            </a:r>
+            <a:endParaRPr lang="en-US" sz="1400" dirty="0"/>
+          </a:p>
+          <a:p>
+            <a:pPr indent="0" marL="0">
+              <a:buNone/>
+            </a:pPr>
+            <a:r>
+              <a:rPr lang="en-US" sz="1400" dirty="0">
+                <a:solidFill>
+                  <a:srgbClr val="C9B5A3"/>
+                </a:solidFill>
+                <a:latin typeface="Courier New" pitchFamily="34" charset="0"/>
+                <a:ea typeface="Courier New" pitchFamily="34" charset="-122"/>
+                <a:cs typeface="Courier New" pitchFamily="34" charset="-120"/>
+              </a:rPr>
+              <a:t>hard-negative hold rate   64%    95% CI 50.7% - 75.7%</a:t>
+            </a:r>
+            <a:endParaRPr lang="en-US" sz="1400" dirty="0"/>
+          </a:p>
+          <a:p>
+            <a:pPr indent="0" marL="0">
+              <a:buNone/>
+            </a:pPr>
+            <a:r>
+              <a:rPr lang="en-US" sz="1400" dirty="0">
+                <a:solidFill>
+                  <a:srgbClr val="C9B5A3"/>
+                </a:solidFill>
+                <a:latin typeface="Courier New" pitchFamily="34" charset="0"/>
+                <a:ea typeface="Courier New" pitchFamily="34" charset="-122"/>
+                <a:cs typeface="Courier New" pitchFamily="34" charset="-120"/>
+              </a:rPr>
+              <a:t>gate latency  n=10000     p50 0.44ms</a:t>
+            </a:r>
+            <a:endParaRPr lang="en-US" sz="1400" dirty="0"/>
+          </a:p>
+          <a:p>
+            <a:pPr indent="0" marL="0">
+              <a:buNone/>
+            </a:pPr>
+            <a:r>
+              <a:rPr lang="en-US" sz="1400" dirty="0">
+                <a:solidFill>
+                  <a:srgbClr val="C9B5A3"/>
+                </a:solidFill>
+                <a:latin typeface="Courier New" pitchFamily="34" charset="0"/>
+                <a:ea typeface="Courier New" pitchFamily="34" charset="-122"/>
+                <a:cs typeface="Courier New" pitchFamily="34" charset="-120"/>
+              </a:rPr>
+              <a:t>                          p95 0.52ms</a:t>
+            </a:r>
+            <a:endParaRPr lang="en-US" sz="1400" dirty="0"/>
+          </a:p>
+          <a:p>
+            <a:pPr indent="0" marL="0">
+              <a:buNone/>
+            </a:pPr>
+            <a:r>
+              <a:rPr lang="en-US" sz="1400" dirty="0">
+                <a:solidFill>
+                  <a:srgbClr val="C9B5A3"/>
+                </a:solidFill>
+                <a:latin typeface="Courier New" pitchFamily="34" charset="0"/>
+                <a:ea typeface="Courier New" pitchFamily="34" charset="-122"/>
+                <a:cs typeface="Courier New" pitchFamily="34" charset="-120"/>
+              </a:rPr>
+              <a:t>                          p99 0.64ms</a:t>
+            </a:r>
+            <a:endParaRPr lang="en-US" sz="1400" dirty="0"/>
+          </a:p>
+        </p:txBody>
+      </p:sp>
+      <p:sp>
+        <p:nvSpPr>
+          <p:cNvPr id="19" name="Shape 16"/>
+          <p:cNvSpPr/>
+          <p:nvPr/>
+        </p:nvSpPr>
+        <p:spPr>
+          <a:xfrm>
+            <a:off x="950976" y="7187184"/>
+            <a:ext cx="9281160" cy="1975104"/>
+          </a:xfrm>
+          <a:prstGeom prst="rect">
+            <a:avLst/>
+          </a:prstGeom>
+          <a:solidFill>
+            <a:srgbClr val="2A140F"/>
+          </a:solidFill>
+          <a:ln w="12700">
+            <a:solidFill>
+              <a:srgbClr val="D9482A"/>
+            </a:solidFill>
+            <a:prstDash val="solid"/>
+          </a:ln>
+        </p:spPr>
+      </p:sp>
+      <p:sp>
+        <p:nvSpPr>
+          <p:cNvPr id="20" name="Shape 17"/>
+          <p:cNvSpPr/>
+          <p:nvPr/>
+        </p:nvSpPr>
+        <p:spPr>
+          <a:xfrm>
+            <a:off x="950976" y="7187184"/>
+            <a:ext cx="9281160" cy="41148"/>
+          </a:xfrm>
+          <a:prstGeom prst="rect">
+            <a:avLst/>
+          </a:prstGeom>
+          <a:solidFill>
+            <a:srgbClr val="D9482A"/>
+          </a:solidFill>
+          <a:ln/>
+        </p:spPr>
+      </p:sp>
+      <p:sp>
+        <p:nvSpPr>
+          <p:cNvPr id="21" name="Text 18"/>
+          <p:cNvSpPr/>
+          <p:nvPr/>
+        </p:nvSpPr>
+        <p:spPr>
+          <a:xfrm>
+            <a:off x="1225296" y="7370064"/>
+            <a:ext cx="8732520" cy="274320"/>
+          </a:xfrm>
+          <a:prstGeom prst="rect">
+            <a:avLst/>
+          </a:prstGeom>
+          <a:noFill/>
+          <a:ln/>
+        </p:spPr>
+        <p:txBody>
+          <a:bodyPr wrap="square" lIns="0" tIns="0" rIns="0" bIns="0" rtlCol="0" anchor="ctr"/>
+          <a:lstStyle/>
+          <a:p>
+            <a:pPr indent="0" marL="0">
+              <a:buNone/>
+            </a:pPr>
+            <a:r>
+              <a:rPr lang="en-US" sz="1200" spc="140" kern="0" dirty="0">
+                <a:solidFill>
+                  <a:srgbClr val="7A5D4E"/>
+                </a:solidFill>
+                <a:latin typeface="Arial" pitchFamily="34" charset="0"/>
+                <a:ea typeface="Arial" pitchFamily="34" charset="-122"/>
+                <a:cs typeface="Arial" pitchFamily="34" charset="-120"/>
+              </a:rPr>
+              <a:t>THE MISS  ·  NAMED, NOT SMOOTHED</a:t>
+            </a:r>
+            <a:endParaRPr lang="en-US" sz="1200" dirty="0"/>
+          </a:p>
+        </p:txBody>
+      </p:sp>
+      <p:sp>
+        <p:nvSpPr>
+          <p:cNvPr id="22" name="Text 19"/>
+          <p:cNvSpPr/>
+          <p:nvPr/>
+        </p:nvSpPr>
+        <p:spPr>
+          <a:xfrm>
+            <a:off x="1225296" y="7717536"/>
+            <a:ext cx="8732520" cy="384048"/>
+          </a:xfrm>
+          <a:prstGeom prst="rect">
+            <a:avLst/>
+          </a:prstGeom>
+          <a:noFill/>
+          <a:ln/>
+        </p:spPr>
+        <p:txBody>
+          <a:bodyPr wrap="square" lIns="0" tIns="0" rIns="0" bIns="0" rtlCol="0" anchor="ctr"/>
+          <a:lstStyle/>
+          <a:p>
+            <a:pPr indent="0" marL="0">
+              <a:buNone/>
+            </a:pPr>
+            <a:r>
+              <a:rPr lang="en-US" sz="2000" b="1" dirty="0">
+                <a:solidFill>
+                  <a:srgbClr val="F2E3D5"/>
+                </a:solidFill>
+                <a:latin typeface="Arial" pitchFamily="34" charset="0"/>
+                <a:ea typeface="Arial" pitchFamily="34" charset="-122"/>
+                <a:cs typeface="Arial" pitchFamily="34" charset="-120"/>
+              </a:rPr>
+              <a:t>Hard-negative hold rate 64% — we over-flag.</a:t>
+            </a:r>
+            <a:endParaRPr lang="en-US" sz="2000" dirty="0"/>
+          </a:p>
+        </p:txBody>
+      </p:sp>
+      <p:sp>
+        <p:nvSpPr>
+          <p:cNvPr id="23" name="Text 20"/>
+          <p:cNvSpPr/>
+          <p:nvPr/>
+        </p:nvSpPr>
+        <p:spPr>
+          <a:xfrm>
+            <a:off x="1225296" y="8174736"/>
+            <a:ext cx="8732520" cy="868680"/>
+          </a:xfrm>
+          <a:prstGeom prst="rect">
+            <a:avLst/>
+          </a:prstGeom>
+          <a:noFill/>
+          <a:ln/>
+        </p:spPr>
+        <p:txBody>
+          <a:bodyPr wrap="square" lIns="0" tIns="0" rIns="0" bIns="0" rtlCol="0" anchor="t"/>
+          <a:lstStyle/>
+          <a:p>
+            <a:pPr indent="0" marL="0">
+              <a:buNone/>
+            </a:pPr>
+            <a:r>
+              <a:rPr lang="en-US" sz="1500" dirty="0">
+                <a:solidFill>
+                  <a:srgbClr val="C9B5A3"/>
+                </a:solidFill>
+                <a:latin typeface="Arial" pitchFamily="34" charset="0"/>
+                <a:ea typeface="Arial" pitchFamily="34" charset="-122"/>
+                <a:cs typeface="Arial" pitchFamily="34" charset="-120"/>
+              </a:rPr>
+              <a:t>Measured, published, and named as the next milestone. 53/168 cases are hard negatives (31.7%). Clean strata hold 0/13.</a:t>
+            </a:r>
+            <a:endParaRPr lang="en-US" sz="1500" dirty="0"/>
+          </a:p>
+        </p:txBody>
+      </p:sp>
+      <p:sp>
+        <p:nvSpPr>
+          <p:cNvPr id="24" name="Shape 21"/>
+          <p:cNvSpPr/>
+          <p:nvPr/>
+        </p:nvSpPr>
+        <p:spPr>
+          <a:xfrm>
+            <a:off x="10442448" y="2121408"/>
+            <a:ext cx="6894576" cy="7040880"/>
+          </a:xfrm>
+          <a:prstGeom prst="rect">
+            <a:avLst/>
+          </a:prstGeom>
+          <a:solidFill>
+            <a:srgbClr val="1A0D0A"/>
+          </a:solidFill>
+          <a:ln w="12700">
+            <a:solidFill>
+              <a:srgbClr val="D9482A"/>
+            </a:solidFill>
+            <a:prstDash val="solid"/>
+          </a:ln>
+        </p:spPr>
+      </p:sp>
+      <p:sp>
+        <p:nvSpPr>
+          <p:cNvPr id="25" name="Shape 22"/>
+          <p:cNvSpPr/>
+          <p:nvPr/>
+        </p:nvSpPr>
+        <p:spPr>
+          <a:xfrm>
+            <a:off x="10442448" y="2121408"/>
+            <a:ext cx="6894576" cy="41148"/>
+          </a:xfrm>
+          <a:prstGeom prst="rect">
+            <a:avLst/>
+          </a:prstGeom>
+          <a:solidFill>
+            <a:srgbClr val="D9482A"/>
+          </a:solidFill>
+          <a:ln/>
+        </p:spPr>
+      </p:sp>
+      <p:sp>
+        <p:nvSpPr>
+          <p:cNvPr id="26" name="Text 23"/>
+          <p:cNvSpPr/>
+          <p:nvPr/>
+        </p:nvSpPr>
+        <p:spPr>
+          <a:xfrm>
+            <a:off x="10716768" y="2304288"/>
+            <a:ext cx="6400800" cy="274320"/>
+          </a:xfrm>
+          <a:prstGeom prst="rect">
+            <a:avLst/>
+          </a:prstGeom>
+          <a:noFill/>
+          <a:ln/>
+        </p:spPr>
+        <p:txBody>
+          <a:bodyPr wrap="square" lIns="0" tIns="0" rIns="0" bIns="0" rtlCol="0" anchor="ctr"/>
+          <a:lstStyle/>
+          <a:p>
+            <a:pPr indent="0" marL="0">
+              <a:buNone/>
+            </a:pPr>
+            <a:r>
+              <a:rPr lang="en-US" sz="1200" spc="120" kern="0" dirty="0">
+                <a:solidFill>
+                  <a:srgbClr val="7A5D4E"/>
+                </a:solidFill>
+                <a:latin typeface="Arial" pitchFamily="34" charset="0"/>
+                <a:ea typeface="Arial" pitchFamily="34" charset="-122"/>
+                <a:cs typeface="Arial" pitchFamily="34" charset="-120"/>
+              </a:rPr>
+              <a:t>WE REFUSE TO CLAIM  ·  ABOUT US, NOT COMPETITORS</a:t>
+            </a:r>
+            <a:endParaRPr lang="en-US" sz="1200" dirty="0"/>
+          </a:p>
+        </p:txBody>
+      </p:sp>
+      <p:sp>
+        <p:nvSpPr>
+          <p:cNvPr id="27" name="Text 24"/>
+          <p:cNvSpPr/>
+          <p:nvPr/>
+        </p:nvSpPr>
+        <p:spPr>
+          <a:xfrm>
+            <a:off x="10716768" y="2688336"/>
+            <a:ext cx="6400800" cy="365760"/>
+          </a:xfrm>
+          <a:prstGeom prst="rect">
+            <a:avLst/>
+          </a:prstGeom>
+          <a:noFill/>
+          <a:ln/>
+        </p:spPr>
+        <p:txBody>
+          <a:bodyPr wrap="square" lIns="0" tIns="0" rIns="0" bIns="0" rtlCol="0" anchor="ctr"/>
+          <a:lstStyle/>
+          <a:p>
+            <a:pPr indent="0" marL="0">
+              <a:buNone/>
+            </a:pPr>
+            <a:r>
+              <a:rPr lang="en-US" sz="2000" b="1" dirty="0">
+                <a:solidFill>
+                  <a:srgbClr val="F2E3D5"/>
+                </a:solidFill>
+                <a:latin typeface="Arial" pitchFamily="34" charset="0"/>
+                <a:ea typeface="Arial" pitchFamily="34" charset="-122"/>
+                <a:cs typeface="Arial" pitchFamily="34" charset="-120"/>
+              </a:rPr>
+              <a:t>We do not claim:</a:t>
+            </a:r>
+            <a:endParaRPr lang="en-US" sz="2000" dirty="0"/>
+          </a:p>
+        </p:txBody>
+      </p:sp>
+      <p:sp>
+        <p:nvSpPr>
+          <p:cNvPr id="28" name="Text 25"/>
+          <p:cNvSpPr/>
+          <p:nvPr/>
+        </p:nvSpPr>
+        <p:spPr>
+          <a:xfrm>
+            <a:off x="10716768" y="3218688"/>
+            <a:ext cx="6400800" cy="2834640"/>
+          </a:xfrm>
+          <a:prstGeom prst="rect">
+            <a:avLst/>
+          </a:prstGeom>
+          <a:noFill/>
+          <a:ln/>
+        </p:spPr>
+        <p:txBody>
+          <a:bodyPr wrap="square" lIns="0" tIns="0" rIns="0" bIns="0" rtlCol="0" anchor="t"/>
+          <a:lstStyle/>
+          <a:p>
+            <a:pPr indent="0" marL="0">
+              <a:buNone/>
+            </a:pPr>
+            <a:r>
+              <a:rPr lang="en-US" sz="1500" dirty="0">
+                <a:solidFill>
+                  <a:srgbClr val="C9B5A3"/>
+                </a:solidFill>
+                <a:latin typeface="Courier New" pitchFamily="34" charset="0"/>
+                <a:ea typeface="Courier New" pitchFamily="34" charset="-122"/>
+                <a:cs typeface="Courier New" pitchFamily="34" charset="-120"/>
+              </a:rPr>
+              <a:t>-  eliminated hallucinations</a:t>
+            </a:r>
+            <a:endParaRPr lang="en-US" sz="1500" dirty="0"/>
+          </a:p>
+          <a:p>
+            <a:pPr indent="0" marL="0">
+              <a:buNone/>
+            </a:pPr>
+            <a:r>
+              <a:rPr lang="en-US" sz="1500" dirty="0">
+                <a:solidFill>
+                  <a:srgbClr val="C9B5A3"/>
+                </a:solidFill>
+                <a:latin typeface="Courier New" pitchFamily="34" charset="0"/>
+                <a:ea typeface="Courier New" pitchFamily="34" charset="-122"/>
+                <a:cs typeface="Courier New" pitchFamily="34" charset="-120"/>
+              </a:rPr>
+              <a:t>-  zero integration</a:t>
+            </a:r>
+            <a:endParaRPr lang="en-US" sz="1500" dirty="0"/>
+          </a:p>
+          <a:p>
+            <a:pPr indent="0" marL="0">
+              <a:buNone/>
+            </a:pPr>
+            <a:r>
+              <a:rPr lang="en-US" sz="1500" dirty="0">
+                <a:solidFill>
+                  <a:srgbClr val="C9B5A3"/>
+                </a:solidFill>
+                <a:latin typeface="Courier New" pitchFamily="34" charset="0"/>
+                <a:ea typeface="Courier New" pitchFamily="34" charset="-122"/>
+                <a:cs typeface="Courier New" pitchFamily="34" charset="-120"/>
+              </a:rPr>
+              <a:t>-  zero added latency</a:t>
+            </a:r>
+            <a:endParaRPr lang="en-US" sz="1500" dirty="0"/>
+          </a:p>
+          <a:p>
+            <a:pPr indent="0" marL="0">
+              <a:buNone/>
+            </a:pPr>
+            <a:r>
+              <a:rPr lang="en-US" sz="1500" dirty="0">
+                <a:solidFill>
+                  <a:srgbClr val="C9B5A3"/>
+                </a:solidFill>
+                <a:latin typeface="Courier New" pitchFamily="34" charset="0"/>
+                <a:ea typeface="Courier New" pitchFamily="34" charset="-122"/>
+                <a:cs typeface="Courier New" pitchFamily="34" charset="-120"/>
+              </a:rPr>
+              <a:t>-  one accuracy number across</a:t>
+            </a:r>
+            <a:endParaRPr lang="en-US" sz="1500" dirty="0"/>
+          </a:p>
+          <a:p>
+            <a:pPr indent="0" marL="0">
+              <a:buNone/>
+            </a:pPr>
+            <a:r>
+              <a:rPr lang="en-US" sz="1500" dirty="0">
+                <a:solidFill>
+                  <a:srgbClr val="C9B5A3"/>
+                </a:solidFill>
+                <a:latin typeface="Courier New" pitchFamily="34" charset="0"/>
+                <a:ea typeface="Courier New" pitchFamily="34" charset="-122"/>
+                <a:cs typeface="Courier New" pitchFamily="34" charset="-120"/>
+              </a:rPr>
+              <a:t>   three failure modes</a:t>
+            </a:r>
+            <a:endParaRPr lang="en-US" sz="1500" dirty="0"/>
+          </a:p>
+          <a:p>
+            <a:pPr indent="0" marL="0">
+              <a:buNone/>
+            </a:pPr>
+            <a:r>
+              <a:rPr lang="en-US" sz="1500" dirty="0">
+                <a:solidFill>
+                  <a:srgbClr val="C9B5A3"/>
+                </a:solidFill>
+                <a:latin typeface="Courier New" pitchFamily="34" charset="0"/>
+                <a:ea typeface="Courier New" pitchFamily="34" charset="-122"/>
+                <a:cs typeface="Courier New" pitchFamily="34" charset="-120"/>
+              </a:rPr>
+              <a:t>-  production-scale proof</a:t>
+            </a:r>
+            <a:endParaRPr lang="en-US" sz="1500" dirty="0"/>
+          </a:p>
+        </p:txBody>
+      </p:sp>
+      <p:sp>
+        <p:nvSpPr>
+          <p:cNvPr id="29" name="Shape 26"/>
+          <p:cNvSpPr/>
+          <p:nvPr/>
+        </p:nvSpPr>
+        <p:spPr>
+          <a:xfrm>
+            <a:off x="10716768" y="6144768"/>
+            <a:ext cx="6400800" cy="9144"/>
+          </a:xfrm>
+          <a:prstGeom prst="rect">
+            <a:avLst/>
+          </a:prstGeom>
+          <a:solidFill>
+            <a:srgbClr val="3A1E16"/>
+          </a:solidFill>
+          <a:ln/>
+        </p:spPr>
+      </p:sp>
+      <p:sp>
+        <p:nvSpPr>
+          <p:cNvPr id="30" name="Text 27"/>
+          <p:cNvSpPr/>
+          <p:nvPr/>
+        </p:nvSpPr>
+        <p:spPr>
+          <a:xfrm>
+            <a:off x="10716768" y="6382512"/>
+            <a:ext cx="6400800" cy="1188720"/>
+          </a:xfrm>
+          <a:prstGeom prst="rect">
+            <a:avLst/>
+          </a:prstGeom>
+          <a:noFill/>
+          <a:ln/>
+        </p:spPr>
+        <p:txBody>
+          <a:bodyPr wrap="square" lIns="0" tIns="0" rIns="0" bIns="0" rtlCol="0" anchor="t"/>
+          <a:lstStyle/>
+          <a:p>
+            <a:pPr indent="0" marL="0">
+              <a:buNone/>
+            </a:pPr>
+            <a:r>
+              <a:rPr lang="en-US" sz="1500" dirty="0">
+                <a:solidFill>
+                  <a:srgbClr val="C9B5A3"/>
+                </a:solidFill>
+                <a:latin typeface="Arial" pitchFamily="34" charset="0"/>
+                <a:ea typeface="Arial" pitchFamily="34" charset="-122"/>
+                <a:cs typeface="Arial" pitchFamily="34" charset="-120"/>
+              </a:rPr>
+              <a:t>What we do claim is bounded: 168 self-authored cases, every rate published with its Wilson interval. Production is unknown until shadow replay.</a:t>
+            </a:r>
+            <a:endParaRPr lang="en-US" sz="1500" dirty="0"/>
+          </a:p>
+        </p:txBody>
+      </p:sp>
+      <p:sp>
+        <p:nvSpPr>
+          <p:cNvPr id="31" name="Text 28"/>
+          <p:cNvSpPr/>
+          <p:nvPr/>
+        </p:nvSpPr>
+        <p:spPr>
+          <a:xfrm>
+            <a:off x="10716768" y="7699248"/>
+            <a:ext cx="6400800" cy="1005840"/>
+          </a:xfrm>
+          <a:prstGeom prst="rect">
+            <a:avLst/>
+          </a:prstGeom>
+          <a:noFill/>
+          <a:ln/>
+        </p:spPr>
+        <p:txBody>
+          <a:bodyPr wrap="square" lIns="0" tIns="0" rIns="0" bIns="0" rtlCol="0" anchor="t"/>
+          <a:lstStyle/>
+          <a:p>
+            <a:pPr indent="0" marL="0">
+              <a:buNone/>
+            </a:pPr>
+            <a:r>
+              <a:rPr lang="en-US" sz="1700" b="1" dirty="0">
+                <a:solidFill>
+                  <a:srgbClr val="F2C572"/>
+                </a:solidFill>
+                <a:latin typeface="Arial" pitchFamily="34" charset="0"/>
+                <a:ea typeface="Arial" pitchFamily="34" charset="-122"/>
+                <a:cs typeface="Arial" pitchFamily="34" charset="-120"/>
+              </a:rPr>
+              <a:t>In the demo, the refund was held and escalated with the evidence packet.</a:t>
+            </a:r>
+            <a:endParaRPr lang="en-US" sz="1700" dirty="0"/>
+          </a:p>
+        </p:txBody>
+      </p:sp>
+    </p:spTree>
+  </p:cSld>
+  <p:clrMapOvr>
+    <a:masterClrMapping/>
+  </p:clrMapOvr>
+</p:sld>
+</file>
+
+<file path=ppt/slides/slide14.xml><?xml version="1.0" encoding="utf-8"?>
+<p:sld xmlns:a="http://schemas.openxmlformats.org/drawingml/2006/main" xmlns:r="http://schemas.openxmlformats.org/officeDocument/2006/relationships" xmlns:p="http://schemas.openxmlformats.org/presentationml/2006/main">
+  <p:cSld name="Slide 14">
+    <p:bg>
+      <p:bgPr>
+        <a:solidFill>
           <a:srgbClr val="0A0504"/>
         </a:solidFill>
       </p:bgPr>
@@ -9502,7 +10832,7 @@
                 <a:ea typeface="Arial" pitchFamily="34" charset="-122"/>
                 <a:cs typeface="Arial" pitchFamily="34" charset="-120"/>
               </a:rPr>
-              <a:t>11 // ASK</a:t>
+              <a:t>12 // ASK</a:t>
             </a:r>
             <a:endParaRPr lang="en-US" sz="1500" dirty="0"/>
           </a:p>

</xml_diff>

<commit_message>
chore(submission): rebuild README/proposal PDFs and PPTX from measured eval/bench
README PDF ledger is honest (implemented vs designed). Proposal FNR CI
matches last_run.json (1.1%, 0.2–5.8%, n=94). Pitch.js loads numbers
from eval/bench JSON so the deck cannot drift.
</commit_message>
<xml_diff>
--- a/submission/ControlPlane_Round2_Pitch.pptx
+++ b/submission/ControlPlane_Round2_Pitch.pptx
@@ -867,7 +867,7 @@
           <a:p>
             <a:r>
               <a:rPr lang="en-US" dirty="0"/>
-              <a:t>This is the honesty slide. Every number here is measured by make eval and make bench on a 168-case self-authored corpus — no production traffic. Ungrounded FNR is 1.1 percent with a Wilson interval of 0.19 to 5.78. Passable-action FPR is 0.0 percent with a 15.5 percent upper bound. The hard-negative hold rate is 64 percent — we over-flag, and we name that as the next milestone rather than hide it. Gate latency over ten thousand runs is p50 0.44ms, p95 0.52ms, p99 0.64ms. Then the refusals, about us and never about competitors: we do not claim eliminated hallucinations, zero integration, zero added latency, one accuracy number, or production-scale proof. In the demo the refund was held and escalated with the evidence packet.</a:t>
+              <a:t>This is the honesty slide. Every number here is measured by make eval and make bench on a 168-case self-authored corpus — no production traffic. Ungrounded FNR is 1.1% with a Wilson interval of 0.2% to 5.8%. Passable-action FPR is 0.0% with a 15.5% upper bound. The hard-negative hold rate is 64% — we over-flag, and we name that as the next milestone rather than hide it. Gate latency over 10000 runs is p50 0.43ms, p95 0.51ms, p99 0.61ms. Published miss: struct-miss-000. Then the refusals, about us and never about competitors: we do not claim eliminated hallucinations, zero integration, zero added latency, one accuracy number, or production-scale proof. In the demo the refund was held and escalated with the evidence packet.</a:t>
             </a:r>
             <a:endParaRPr lang="en-US" dirty="0"/>
           </a:p>
@@ -8207,7 +8207,7 @@
                 <a:ea typeface="Arial" pitchFamily="34" charset="-122"/>
                 <a:cs typeface="Arial" pitchFamily="34" charset="-120"/>
               </a:rPr>
-              <a:t>Measured gate (submission/latency_bench.json, n=10000): p50≈0.43 ms · p95≈0.51 ms — under target; quote measured vs targets separately.</a:t>
+              <a:t>Measured gate (submission/latency_bench.json, n=10000): p50=0.43 ms · p95=0.51 ms — under target; quote measured vs targets separately.</a:t>
             </a:r>
             <a:endParaRPr lang="en-US" sz="1400" dirty="0"/>
           </a:p>
@@ -8699,7 +8699,7 @@
                 <a:ea typeface="Arial" pitchFamily="34" charset="-122"/>
                 <a:cs typeface="Arial" pitchFamily="34" charset="-120"/>
               </a:rPr>
-              <a:t>Per route. Not what we caught — what we missed. Gate report: empty schema. The emptiness is the claim.</a:t>
+              <a:t>Per route. Not what we caught — what we missed. Schema empty until earned. This build: 1.1% FNR (0.2%–5.8%) on a self-authored corpus — next slide.</a:t>
             </a:r>
             <a:endParaRPr lang="en-US" sz="1500" dirty="0"/>
           </a:p>
@@ -10069,7 +10069,7 @@
                 <a:ea typeface="Courier New" pitchFamily="34" charset="-122"/>
                 <a:cs typeface="Courier New" pitchFamily="34" charset="-120"/>
               </a:rPr>
-              <a:t>ungrounded FNR            1.1%   95% CI 0.19% - 5.78%</a:t>
+              <a:t>ungrounded FNR            1.1%   95% CI 0.2% - 5.8%</a:t>
             </a:r>
             <a:endParaRPr lang="en-US" sz="1400" dirty="0"/>
           </a:p>
@@ -10120,7 +10120,7 @@
                 <a:ea typeface="Courier New" pitchFamily="34" charset="-122"/>
                 <a:cs typeface="Courier New" pitchFamily="34" charset="-120"/>
               </a:rPr>
-              <a:t>gate latency  n=10000     p50 0.44ms</a:t>
+              <a:t>gate latency  n=10000     p50 0.43ms</a:t>
             </a:r>
             <a:endParaRPr lang="en-US" sz="1400" dirty="0"/>
           </a:p>
@@ -10137,7 +10137,7 @@
                 <a:ea typeface="Courier New" pitchFamily="34" charset="-122"/>
                 <a:cs typeface="Courier New" pitchFamily="34" charset="-120"/>
               </a:rPr>
-              <a:t>                          p95 0.52ms</a:t>
+              <a:t>                          p95 0.51ms</a:t>
             </a:r>
             <a:endParaRPr lang="en-US" sz="1400" dirty="0"/>
           </a:p>
@@ -10154,7 +10154,7 @@
                 <a:ea typeface="Courier New" pitchFamily="34" charset="-122"/>
                 <a:cs typeface="Courier New" pitchFamily="34" charset="-120"/>
               </a:rPr>
-              <a:t>                          p99 0.64ms</a:t>
+              <a:t>                          p99 0.61ms</a:t>
             </a:r>
             <a:endParaRPr lang="en-US" sz="1400" dirty="0"/>
           </a:p>
@@ -10316,7 +10316,7 @@
                 <a:ea typeface="Arial" pitchFamily="34" charset="-122"/>
                 <a:cs typeface="Arial" pitchFamily="34" charset="-120"/>
               </a:rPr>
-              <a:t>Measured, published, and named as the next milestone. 53/168 cases are hard negatives (31.7%). Clean strata hold 0/13.</a:t>
+              <a:t>Measured, published, and named as the next milestone. 53/168 cases are hard negatives (31.5%). Published miss: struct-miss-000.</a:t>
             </a:r>
             <a:endParaRPr lang="en-US" sz="1500" dirty="0"/>
           </a:p>

</xml_diff>

<commit_message>
FIX: mux audio into prototype video (210s, 1080p, voice), clean messy video work duplicates, hide unnecessary agent artifacts, update .gitignore. Video now has embedded AAC audio. Submissions verified: proposal PDF 15pp, pitch PPTX 14 slides rebuilt from JS, README PDF 4pp, latency bench n=10000, pytest 348 passed, graphify build 1501 nodes. Refund language: held/escalated. No 'blocked'.
</commit_message>
<xml_diff>
--- a/submission/ControlPlane_Round2_Pitch.pptx
+++ b/submission/ControlPlane_Round2_Pitch.pptx
@@ -867,7 +867,7 @@
           <a:p>
             <a:r>
               <a:rPr lang="en-US" dirty="0"/>
-              <a:t>This is the honesty slide. Every number here is measured by make eval and make bench on a 168-case self-authored corpus — no production traffic. Ungrounded FNR is 1.1% with a Wilson interval of 0.2% to 5.8%. Passable-action FPR is 0.0% with a 15.5% upper bound. The hard-negative hold rate is 64% — we over-flag, and we name that as the next milestone rather than hide it. Gate latency over 10000 runs is p50 0.43ms, p95 0.51ms, p99 0.61ms. Published miss: struct-miss-000. Then the refusals, about us and never about competitors: we do not claim eliminated hallucinations, zero integration, zero added latency, one accuracy number, or production-scale proof. In the demo the refund was held and escalated with the evidence packet.</a:t>
+              <a:t>This is the honesty slide. Every number here is measured by make eval and make bench on a 168-case self-authored corpus — no production traffic. Ungrounded FNR is 1.1% with a Wilson interval of 0.2% to 5.8%. Passable-action FPR is 0.0% with a 15.5% upper bound. The hard-negative hold rate is 64% — we over-flag, and we name that as the next milestone rather than hide it. Gate latency over 10000 runs is p50 0.42ms, p95 0.49ms, p99 0.59ms. Published miss: struct-miss-000. Then the refusals, about us and never about competitors: we do not claim eliminated hallucinations, zero integration, zero added latency, one accuracy number, or production-scale proof. In the demo the refund was held and escalated with the evidence packet.</a:t>
             </a:r>
             <a:endParaRPr lang="en-US" dirty="0"/>
           </a:p>
@@ -8207,7 +8207,7 @@
                 <a:ea typeface="Arial" pitchFamily="34" charset="-122"/>
                 <a:cs typeface="Arial" pitchFamily="34" charset="-120"/>
               </a:rPr>
-              <a:t>Measured gate (submission/latency_bench.json, n=10000): p50=0.43 ms · p95=0.51 ms — under target; quote measured vs targets separately.</a:t>
+              <a:t>Measured gate (submission/latency_bench.json, n=10000): p50=0.42 ms · p95=0.49 ms — under target; quote measured vs targets separately.</a:t>
             </a:r>
             <a:endParaRPr lang="en-US" sz="1400" dirty="0"/>
           </a:p>
@@ -10120,7 +10120,7 @@
                 <a:ea typeface="Courier New" pitchFamily="34" charset="-122"/>
                 <a:cs typeface="Courier New" pitchFamily="34" charset="-120"/>
               </a:rPr>
-              <a:t>gate latency  n=10000     p50 0.43ms</a:t>
+              <a:t>gate latency  n=10000     p50 0.42ms</a:t>
             </a:r>
             <a:endParaRPr lang="en-US" sz="1400" dirty="0"/>
           </a:p>
@@ -10137,7 +10137,7 @@
                 <a:ea typeface="Courier New" pitchFamily="34" charset="-122"/>
                 <a:cs typeface="Courier New" pitchFamily="34" charset="-120"/>
               </a:rPr>
-              <a:t>                          p95 0.51ms</a:t>
+              <a:t>                          p95 0.49ms</a:t>
             </a:r>
             <a:endParaRPr lang="en-US" sz="1400" dirty="0"/>
           </a:p>
@@ -10154,7 +10154,7 @@
                 <a:ea typeface="Courier New" pitchFamily="34" charset="-122"/>
                 <a:cs typeface="Courier New" pitchFamily="34" charset="-120"/>
               </a:rPr>
-              <a:t>                          p99 0.61ms</a:t>
+              <a:t>                          p99 0.59ms</a:t>
             </a:r>
             <a:endParaRPr lang="en-US" sz="1400" dirty="0"/>
           </a:p>

</xml_diff>